<commit_message>
Restore SmartCourse project name in simplified deck
</commit_message>
<xml_diff>
--- a/project-documents/SmartCourse_Project_Presentation_Simple.pptx
+++ b/project-documents/SmartCourse_Project_Presentation_Simple.pptx
@@ -2,26 +2,26 @@
 <file path=ppt/presentation.xml><?xml version="1.0" encoding="utf-8"?>
 <p:presentation xmlns:p="http://schemas.openxmlformats.org/presentationml/2006/main">
   <p:sldMasterIdLst>
-    <p:sldMasterId xmlns:r="http://schemas.openxmlformats.org/officeDocument/2006/relationships" id="2147483648" r:id="R64121fe992b74a70"/>
+    <p:sldMasterId xmlns:r="http://schemas.openxmlformats.org/officeDocument/2006/relationships" id="2147483648" r:id="Rf62a0cd326f943c2"/>
   </p:sldMasterIdLst>
   <p:notesMasterIdLst>
-    <p:notesMasterId xmlns:r="http://schemas.openxmlformats.org/officeDocument/2006/relationships" r:id="R11cc285101f44a22"/>
+    <p:notesMasterId xmlns:r="http://schemas.openxmlformats.org/officeDocument/2006/relationships" r:id="Rde7109d880c5400c"/>
   </p:notesMasterIdLst>
   <p:sldIdLst>
-    <p:sldId xmlns:r="http://schemas.openxmlformats.org/officeDocument/2006/relationships" id="256" r:id="R8385c4b46a694f1b"/>
-    <p:sldId xmlns:r="http://schemas.openxmlformats.org/officeDocument/2006/relationships" id="257" r:id="R8117203951184d3a"/>
-    <p:sldId xmlns:r="http://schemas.openxmlformats.org/officeDocument/2006/relationships" id="258" r:id="R43d6875d94a64a16"/>
-    <p:sldId xmlns:r="http://schemas.openxmlformats.org/officeDocument/2006/relationships" id="259" r:id="Rccfe4b1ea39546ed"/>
-    <p:sldId xmlns:r="http://schemas.openxmlformats.org/officeDocument/2006/relationships" id="260" r:id="R8e4bc4cc9c564c94"/>
-    <p:sldId xmlns:r="http://schemas.openxmlformats.org/officeDocument/2006/relationships" id="261" r:id="R6a975b492f5141c1"/>
-    <p:sldId xmlns:r="http://schemas.openxmlformats.org/officeDocument/2006/relationships" id="262" r:id="R025d23f8d6ae452e"/>
-    <p:sldId xmlns:r="http://schemas.openxmlformats.org/officeDocument/2006/relationships" id="263" r:id="R0e5cb1dc6b11455e"/>
-    <p:sldId xmlns:r="http://schemas.openxmlformats.org/officeDocument/2006/relationships" id="264" r:id="R06ff223a108b4c83"/>
-    <p:sldId xmlns:r="http://schemas.openxmlformats.org/officeDocument/2006/relationships" id="265" r:id="R7b5e16969f83457b"/>
-    <p:sldId xmlns:r="http://schemas.openxmlformats.org/officeDocument/2006/relationships" id="266" r:id="R2f16c3ff25bd4703"/>
-    <p:sldId xmlns:r="http://schemas.openxmlformats.org/officeDocument/2006/relationships" id="267" r:id="R1010274a0f184804"/>
-    <p:sldId xmlns:r="http://schemas.openxmlformats.org/officeDocument/2006/relationships" id="268" r:id="R87937df758954e5a"/>
-    <p:sldId xmlns:r="http://schemas.openxmlformats.org/officeDocument/2006/relationships" id="269" r:id="R87c2b82e991345fb"/>
+    <p:sldId xmlns:r="http://schemas.openxmlformats.org/officeDocument/2006/relationships" id="256" r:id="R0bfd50d747434d10"/>
+    <p:sldId xmlns:r="http://schemas.openxmlformats.org/officeDocument/2006/relationships" id="257" r:id="R57da43e044964737"/>
+    <p:sldId xmlns:r="http://schemas.openxmlformats.org/officeDocument/2006/relationships" id="258" r:id="R1ee1f7ddd0b8424c"/>
+    <p:sldId xmlns:r="http://schemas.openxmlformats.org/officeDocument/2006/relationships" id="259" r:id="R36aa2ebe875b49e4"/>
+    <p:sldId xmlns:r="http://schemas.openxmlformats.org/officeDocument/2006/relationships" id="260" r:id="Rdf8a6da4d1714205"/>
+    <p:sldId xmlns:r="http://schemas.openxmlformats.org/officeDocument/2006/relationships" id="261" r:id="R0e4e27d51dab4401"/>
+    <p:sldId xmlns:r="http://schemas.openxmlformats.org/officeDocument/2006/relationships" id="262" r:id="R521b6fe7c8784ac3"/>
+    <p:sldId xmlns:r="http://schemas.openxmlformats.org/officeDocument/2006/relationships" id="263" r:id="R01fb2cdba87441c3"/>
+    <p:sldId xmlns:r="http://schemas.openxmlformats.org/officeDocument/2006/relationships" id="264" r:id="R66facadcbc34425e"/>
+    <p:sldId xmlns:r="http://schemas.openxmlformats.org/officeDocument/2006/relationships" id="265" r:id="Rbf9db1e25b1c4bdc"/>
+    <p:sldId xmlns:r="http://schemas.openxmlformats.org/officeDocument/2006/relationships" id="266" r:id="R28c0fc76fce54428"/>
+    <p:sldId xmlns:r="http://schemas.openxmlformats.org/officeDocument/2006/relationships" id="267" r:id="Rfb96dd56af5b4403"/>
+    <p:sldId xmlns:r="http://schemas.openxmlformats.org/officeDocument/2006/relationships" id="268" r:id="R23612d1a3048424c"/>
+    <p:sldId xmlns:r="http://schemas.openxmlformats.org/officeDocument/2006/relationships" id="269" r:id="R46063cc15fbb4154"/>
   </p:sldIdLst>
   <p:sldSz cx="12192000" cy="6858000"/>
   <p:notesSz cx="6858000" cy="9144000"/>
@@ -1838,7 +1838,7 @@
   </p:cSld>
   <p:clrMap bg1="lt1" tx1="dk1" bg2="lt2" tx2="dk2" accent1="accent1" accent2="accent2" accent3="accent3" accent4="accent4" accent5="accent5" accent6="accent6" hlink="hlink" folHlink="folHlink"/>
   <p:sldLayoutIdLst>
-    <p:sldLayoutId xmlns:r="http://schemas.openxmlformats.org/officeDocument/2006/relationships" id="2147483649" r:id="R287ac717507440aa"/>
+    <p:sldLayoutId xmlns:r="http://schemas.openxmlformats.org/officeDocument/2006/relationships" id="2147483649" r:id="Rdbd1e4218fff4fee"/>
   </p:sldLayoutIdLst>
   <p:txStyles>
     <p:titleStyle>
@@ -2539,7 +2539,7 @@
                 <a:ea typeface="Aptos"/>
                 <a:cs typeface="Aptos"/>
               </a:rPr>
-              <a:t>SMARTCOURSE</a:t>
+              <a:t>AI-POWERED COURSE</a:t>
             </a:r>
           </a:p>
           <a:p xmlns:a="http://schemas.openxmlformats.org/drawingml/2006/main">
@@ -2563,7 +2563,7 @@
                 <a:ea typeface="Aptos"/>
                 <a:cs typeface="Aptos"/>
               </a:rPr>
-              <a:t>AI COURSE FINDER</a:t>
+              <a:t>RECOMMENDATION SYSTEM</a:t>
             </a:r>
           </a:p>
         </p:txBody>
@@ -20344,7 +20344,7 @@
           <p:nvPr/>
         </p:nvPicPr>
         <p:blipFill>
-          <a:blip xmlns:r="http://schemas.openxmlformats.org/officeDocument/2006/relationships" xmlns:a="http://schemas.openxmlformats.org/drawingml/2006/main" r:embed="Rd6028e615a7f495d"/>
+          <a:blip xmlns:r="http://schemas.openxmlformats.org/officeDocument/2006/relationships" xmlns:a="http://schemas.openxmlformats.org/drawingml/2006/main" r:embed="Rb9ffd05fa0ae4288"/>
           <a:srcRect xmlns:a="http://schemas.openxmlformats.org/drawingml/2006/main" l="111" t="0" r="111" b="0"/>
           <a:stretch xmlns:a="http://schemas.openxmlformats.org/drawingml/2006/main">
             <a:fillRect l="0" t="0" r="0" b="0"/>
@@ -20471,7 +20471,7 @@
           <p:nvPr/>
         </p:nvPicPr>
         <p:blipFill>
-          <a:blip xmlns:r="http://schemas.openxmlformats.org/officeDocument/2006/relationships" xmlns:a="http://schemas.openxmlformats.org/drawingml/2006/main" r:embed="Rb78cebf16ee440ea"/>
+          <a:blip xmlns:r="http://schemas.openxmlformats.org/officeDocument/2006/relationships" xmlns:a="http://schemas.openxmlformats.org/drawingml/2006/main" r:embed="R5bfcb85ee35c4002"/>
           <a:srcRect xmlns:a="http://schemas.openxmlformats.org/drawingml/2006/main" l="0" t="4720" r="0" b="4720"/>
           <a:stretch xmlns:a="http://schemas.openxmlformats.org/drawingml/2006/main">
             <a:fillRect l="0" t="0" r="0" b="0"/>
@@ -20953,7 +20953,7 @@
           <p:nvPr/>
         </p:nvPicPr>
         <p:blipFill>
-          <a:blip xmlns:r="http://schemas.openxmlformats.org/officeDocument/2006/relationships" xmlns:a="http://schemas.openxmlformats.org/drawingml/2006/main" r:embed="R4ff45bce08a144de"/>
+          <a:blip xmlns:r="http://schemas.openxmlformats.org/officeDocument/2006/relationships" xmlns:a="http://schemas.openxmlformats.org/drawingml/2006/main" r:embed="Rdbeaa8a13af74eb6"/>
           <a:srcRect xmlns:a="http://schemas.openxmlformats.org/drawingml/2006/main" l="0" t="22010" r="0" b="22010"/>
           <a:stretch xmlns:a="http://schemas.openxmlformats.org/drawingml/2006/main">
             <a:fillRect l="0" t="0" r="0" b="0"/>

</xml_diff>